<commit_message>
Moved all powerpoints to git from network drive
</commit_message>
<xml_diff>
--- a/embedded/RC_and_Ardupilot/Ardupilot PixHawk Autonomous.pptx
+++ b/embedded/RC_and_Ardupilot/Ardupilot PixHawk Autonomous.pptx
@@ -9,10 +9,13 @@
     <p:sldId id="259" r:id="rId3"/>
     <p:sldId id="263" r:id="rId4"/>
     <p:sldId id="258" r:id="rId5"/>
-    <p:sldId id="264" r:id="rId6"/>
-    <p:sldId id="261" r:id="rId7"/>
-    <p:sldId id="260" r:id="rId8"/>
-    <p:sldId id="262" r:id="rId9"/>
+    <p:sldId id="267" r:id="rId6"/>
+    <p:sldId id="264" r:id="rId7"/>
+    <p:sldId id="265" r:id="rId8"/>
+    <p:sldId id="266" r:id="rId9"/>
+    <p:sldId id="261" r:id="rId10"/>
+    <p:sldId id="260" r:id="rId11"/>
+    <p:sldId id="262" r:id="rId12"/>
   </p:sldIdLst>
   <p:sldSz cx="12192000" cy="6858000"/>
   <p:notesSz cx="6858000" cy="9144000"/>
@@ -250,7 +253,7 @@
           <a:p>
             <a:fld id="{D91D2BBE-308B-4063-9087-B87F538B8AD5}" type="datetimeFigureOut">
               <a:rPr lang="en-US" smtClean="0"/>
-              <a:t>12/21/2024</a:t>
+              <a:t>6/13/2025</a:t>
             </a:fld>
             <a:endParaRPr lang="en-US"/>
           </a:p>
@@ -420,7 +423,7 @@
           <a:p>
             <a:fld id="{D91D2BBE-308B-4063-9087-B87F538B8AD5}" type="datetimeFigureOut">
               <a:rPr lang="en-US" smtClean="0"/>
-              <a:t>12/21/2024</a:t>
+              <a:t>6/13/2025</a:t>
             </a:fld>
             <a:endParaRPr lang="en-US"/>
           </a:p>
@@ -600,7 +603,7 @@
           <a:p>
             <a:fld id="{D91D2BBE-308B-4063-9087-B87F538B8AD5}" type="datetimeFigureOut">
               <a:rPr lang="en-US" smtClean="0"/>
-              <a:t>12/21/2024</a:t>
+              <a:t>6/13/2025</a:t>
             </a:fld>
             <a:endParaRPr lang="en-US"/>
           </a:p>
@@ -770,7 +773,7 @@
           <a:p>
             <a:fld id="{D91D2BBE-308B-4063-9087-B87F538B8AD5}" type="datetimeFigureOut">
               <a:rPr lang="en-US" smtClean="0"/>
-              <a:t>12/21/2024</a:t>
+              <a:t>6/13/2025</a:t>
             </a:fld>
             <a:endParaRPr lang="en-US"/>
           </a:p>
@@ -1016,7 +1019,7 @@
           <a:p>
             <a:fld id="{D91D2BBE-308B-4063-9087-B87F538B8AD5}" type="datetimeFigureOut">
               <a:rPr lang="en-US" smtClean="0"/>
-              <a:t>12/21/2024</a:t>
+              <a:t>6/13/2025</a:t>
             </a:fld>
             <a:endParaRPr lang="en-US"/>
           </a:p>
@@ -1248,7 +1251,7 @@
           <a:p>
             <a:fld id="{D91D2BBE-308B-4063-9087-B87F538B8AD5}" type="datetimeFigureOut">
               <a:rPr lang="en-US" smtClean="0"/>
-              <a:t>12/21/2024</a:t>
+              <a:t>6/13/2025</a:t>
             </a:fld>
             <a:endParaRPr lang="en-US"/>
           </a:p>
@@ -1615,7 +1618,7 @@
           <a:p>
             <a:fld id="{D91D2BBE-308B-4063-9087-B87F538B8AD5}" type="datetimeFigureOut">
               <a:rPr lang="en-US" smtClean="0"/>
-              <a:t>12/21/2024</a:t>
+              <a:t>6/13/2025</a:t>
             </a:fld>
             <a:endParaRPr lang="en-US"/>
           </a:p>
@@ -1733,7 +1736,7 @@
           <a:p>
             <a:fld id="{D91D2BBE-308B-4063-9087-B87F538B8AD5}" type="datetimeFigureOut">
               <a:rPr lang="en-US" smtClean="0"/>
-              <a:t>12/21/2024</a:t>
+              <a:t>6/13/2025</a:t>
             </a:fld>
             <a:endParaRPr lang="en-US"/>
           </a:p>
@@ -1828,7 +1831,7 @@
           <a:p>
             <a:fld id="{D91D2BBE-308B-4063-9087-B87F538B8AD5}" type="datetimeFigureOut">
               <a:rPr lang="en-US" smtClean="0"/>
-              <a:t>12/21/2024</a:t>
+              <a:t>6/13/2025</a:t>
             </a:fld>
             <a:endParaRPr lang="en-US"/>
           </a:p>
@@ -2105,7 +2108,7 @@
           <a:p>
             <a:fld id="{D91D2BBE-308B-4063-9087-B87F538B8AD5}" type="datetimeFigureOut">
               <a:rPr lang="en-US" smtClean="0"/>
-              <a:t>12/21/2024</a:t>
+              <a:t>6/13/2025</a:t>
             </a:fld>
             <a:endParaRPr lang="en-US"/>
           </a:p>
@@ -2358,7 +2361,7 @@
           <a:p>
             <a:fld id="{D91D2BBE-308B-4063-9087-B87F538B8AD5}" type="datetimeFigureOut">
               <a:rPr lang="en-US" smtClean="0"/>
-              <a:t>12/21/2024</a:t>
+              <a:t>6/13/2025</a:t>
             </a:fld>
             <a:endParaRPr lang="en-US"/>
           </a:p>
@@ -2571,7 +2574,7 @@
           <a:p>
             <a:fld id="{D91D2BBE-308B-4063-9087-B87F538B8AD5}" type="datetimeFigureOut">
               <a:rPr lang="en-US" smtClean="0"/>
-              <a:t>12/21/2024</a:t>
+              <a:t>6/13/2025</a:t>
             </a:fld>
             <a:endParaRPr lang="en-US"/>
           </a:p>
@@ -3035,6 +3038,247 @@
 </p:sld>
 </file>
 
+<file path=ppt/slides/slide10.xml><?xml version="1.0" encoding="utf-8"?>
+<p:sld xmlns:a="http://schemas.openxmlformats.org/drawingml/2006/main" xmlns:r="http://schemas.openxmlformats.org/officeDocument/2006/relationships" xmlns:p="http://schemas.openxmlformats.org/presentationml/2006/main">
+  <p:cSld>
+    <p:spTree>
+      <p:nvGrpSpPr>
+        <p:cNvPr id="1" name=""/>
+        <p:cNvGrpSpPr/>
+        <p:nvPr/>
+      </p:nvGrpSpPr>
+      <p:grpSpPr>
+        <a:xfrm>
+          <a:off x="0" y="0"/>
+          <a:ext cx="0" cy="0"/>
+          <a:chOff x="0" y="0"/>
+          <a:chExt cx="0" cy="0"/>
+        </a:xfrm>
+      </p:grpSpPr>
+      <p:sp>
+        <p:nvSpPr>
+          <p:cNvPr id="2" name="Title 1"/>
+          <p:cNvSpPr>
+            <a:spLocks noGrp="1"/>
+          </p:cNvSpPr>
+          <p:nvPr>
+            <p:ph type="title"/>
+          </p:nvPr>
+        </p:nvSpPr>
+        <p:spPr>
+          <a:xfrm>
+            <a:off x="838201" y="365125"/>
+            <a:ext cx="1386254" cy="5472967"/>
+          </a:xfrm>
+        </p:spPr>
+        <p:txBody>
+          <a:bodyPr>
+            <a:normAutofit/>
+          </a:bodyPr>
+          <a:lstStyle/>
+          <a:p>
+            <a:r>
+              <a:rPr lang="en-US" sz="2400" dirty="0" err="1" smtClean="0"/>
+              <a:t>CubePilot</a:t>
+            </a:r>
+            <a:r>
+              <a:rPr lang="en-US" sz="2400" dirty="0" smtClean="0"/>
+              <a:t> Cube Orange+</a:t>
+            </a:r>
+            <a:endParaRPr lang="en-US" sz="2400" dirty="0"/>
+          </a:p>
+        </p:txBody>
+      </p:sp>
+      <p:pic>
+        <p:nvPicPr>
+          <p:cNvPr id="1026" name="Picture 2" descr="https://discuss.ardupilot.org/uploads/default/original/3X/0/b/0b28377ded225ec3c485b9342cb86fb1ff5a5c22.jpeg"/>
+          <p:cNvPicPr>
+            <a:picLocks noGrp="1" noChangeAspect="1" noChangeArrowheads="1"/>
+          </p:cNvPicPr>
+          <p:nvPr>
+            <p:ph idx="1"/>
+          </p:nvPr>
+        </p:nvPicPr>
+        <p:blipFill>
+          <a:blip r:embed="rId2" cstate="print">
+            <a:extLst>
+              <a:ext uri="{28A0092B-C50C-407E-A947-70E740481C1C}">
+                <a14:useLocalDpi xmlns:a14="http://schemas.microsoft.com/office/drawing/2010/main" val="0"/>
+              </a:ext>
+            </a:extLst>
+          </a:blip>
+          <a:srcRect/>
+          <a:stretch>
+            <a:fillRect/>
+          </a:stretch>
+        </p:blipFill>
+        <p:spPr bwMode="auto">
+          <a:xfrm>
+            <a:off x="3077308" y="2746"/>
+            <a:ext cx="5169877" cy="6893171"/>
+          </a:xfrm>
+          <a:prstGeom prst="rect">
+            <a:avLst/>
+          </a:prstGeom>
+          <a:noFill/>
+          <a:extLst>
+            <a:ext uri="{909E8E84-426E-40DD-AFC4-6F175D3DCCD1}">
+              <a14:hiddenFill xmlns:a14="http://schemas.microsoft.com/office/drawing/2010/main">
+                <a:solidFill>
+                  <a:srgbClr val="FFFFFF"/>
+                </a:solidFill>
+              </a14:hiddenFill>
+            </a:ext>
+          </a:extLst>
+        </p:spPr>
+      </p:pic>
+    </p:spTree>
+    <p:extLst>
+      <p:ext uri="{BB962C8B-B14F-4D97-AF65-F5344CB8AC3E}">
+        <p14:creationId xmlns:p14="http://schemas.microsoft.com/office/powerpoint/2010/main" val="3806912843"/>
+      </p:ext>
+    </p:extLst>
+  </p:cSld>
+  <p:clrMapOvr>
+    <a:masterClrMapping/>
+  </p:clrMapOvr>
+</p:sld>
+</file>
+
+<file path=ppt/slides/slide11.xml><?xml version="1.0" encoding="utf-8"?>
+<p:sld xmlns:a="http://schemas.openxmlformats.org/drawingml/2006/main" xmlns:r="http://schemas.openxmlformats.org/officeDocument/2006/relationships" xmlns:p="http://schemas.openxmlformats.org/presentationml/2006/main">
+  <p:cSld>
+    <p:spTree>
+      <p:nvGrpSpPr>
+        <p:cNvPr id="1" name=""/>
+        <p:cNvGrpSpPr/>
+        <p:nvPr/>
+      </p:nvGrpSpPr>
+      <p:grpSpPr>
+        <a:xfrm>
+          <a:off x="0" y="0"/>
+          <a:ext cx="0" cy="0"/>
+          <a:chOff x="0" y="0"/>
+          <a:chExt cx="0" cy="0"/>
+        </a:xfrm>
+      </p:grpSpPr>
+      <p:sp>
+        <p:nvSpPr>
+          <p:cNvPr id="2" name="Title 1"/>
+          <p:cNvSpPr>
+            <a:spLocks noGrp="1"/>
+          </p:cNvSpPr>
+          <p:nvPr>
+            <p:ph type="title"/>
+          </p:nvPr>
+        </p:nvSpPr>
+        <p:spPr/>
+        <p:txBody>
+          <a:bodyPr/>
+          <a:lstStyle/>
+          <a:p>
+            <a:r>
+              <a:rPr lang="en-US" dirty="0" smtClean="0"/>
+              <a:t>Ground Control Software</a:t>
+            </a:r>
+            <a:endParaRPr lang="en-US" dirty="0"/>
+          </a:p>
+        </p:txBody>
+      </p:sp>
+      <p:sp>
+        <p:nvSpPr>
+          <p:cNvPr id="3" name="Content Placeholder 2"/>
+          <p:cNvSpPr>
+            <a:spLocks noGrp="1"/>
+          </p:cNvSpPr>
+          <p:nvPr>
+            <p:ph idx="1"/>
+          </p:nvPr>
+        </p:nvSpPr>
+        <p:spPr/>
+        <p:txBody>
+          <a:bodyPr/>
+          <a:lstStyle/>
+          <a:p>
+            <a:r>
+              <a:rPr lang="en-US" dirty="0" smtClean="0"/>
+              <a:t>Mission Planner is most popular and easiest, but also:</a:t>
+            </a:r>
+          </a:p>
+          <a:p>
+            <a:pPr lvl="2"/>
+            <a:r>
+              <a:rPr lang="en-US" dirty="0" err="1" smtClean="0"/>
+              <a:t>QGroundControl</a:t>
+            </a:r>
+            <a:endParaRPr lang="en-US" dirty="0" smtClean="0"/>
+          </a:p>
+          <a:p>
+            <a:pPr lvl="2"/>
+            <a:r>
+              <a:rPr lang="en-US" dirty="0" smtClean="0"/>
+              <a:t>APM Planner 2</a:t>
+            </a:r>
+          </a:p>
+          <a:p>
+            <a:pPr lvl="2"/>
+            <a:r>
+              <a:rPr lang="en-US" dirty="0" smtClean="0"/>
+              <a:t>could also run app from phone or tablet</a:t>
+            </a:r>
+          </a:p>
+          <a:p>
+            <a:r>
+              <a:rPr lang="en-US" dirty="0" smtClean="0"/>
+              <a:t>Used to flash firmware onto the flight controller hardware</a:t>
+            </a:r>
+          </a:p>
+          <a:p>
+            <a:r>
+              <a:rPr lang="en-US" dirty="0" smtClean="0"/>
+              <a:t>Used to monitor flight and control vehicle remotely</a:t>
+            </a:r>
+          </a:p>
+          <a:p>
+            <a:pPr lvl="1"/>
+            <a:r>
+              <a:rPr lang="en-US" dirty="0" smtClean="0"/>
+              <a:t>Can use in combination with a joystick-type controller, but it’s possible to have no controller at all. The point is an autonomous flight plan, anyways.</a:t>
+            </a:r>
+          </a:p>
+          <a:p>
+            <a:pPr lvl="1"/>
+            <a:r>
+              <a:rPr lang="en-US" dirty="0" smtClean="0"/>
+              <a:t>Can stop the flight and call back </a:t>
+            </a:r>
+            <a:r>
+              <a:rPr lang="en-US" smtClean="0"/>
+              <a:t>to home, etc.</a:t>
+            </a:r>
+            <a:endParaRPr lang="en-US" dirty="0" smtClean="0"/>
+          </a:p>
+          <a:p>
+            <a:endParaRPr lang="en-US" dirty="0" smtClean="0"/>
+          </a:p>
+          <a:p>
+            <a:endParaRPr lang="en-US" dirty="0"/>
+          </a:p>
+        </p:txBody>
+      </p:sp>
+    </p:spTree>
+    <p:extLst>
+      <p:ext uri="{BB962C8B-B14F-4D97-AF65-F5344CB8AC3E}">
+        <p14:creationId xmlns:p14="http://schemas.microsoft.com/office/powerpoint/2010/main" val="4237575968"/>
+      </p:ext>
+    </p:extLst>
+  </p:cSld>
+  <p:clrMapOvr>
+    <a:masterClrMapping/>
+  </p:clrMapOvr>
+</p:sld>
+</file>
+
 <file path=ppt/slides/slide2.xml><?xml version="1.0" encoding="utf-8"?>
 <p:sld xmlns:a="http://schemas.openxmlformats.org/drawingml/2006/main" xmlns:r="http://schemas.openxmlformats.org/officeDocument/2006/relationships" xmlns:p="http://schemas.openxmlformats.org/presentationml/2006/main">
   <p:cSld>
@@ -3206,7 +3450,11 @@
           <a:p>
             <a:r>
               <a:rPr lang="en-US" dirty="0" smtClean="0"/>
-              <a:t>Flight Controller Hardware</a:t>
+              <a:t>Types of Flight </a:t>
+            </a:r>
+            <a:r>
+              <a:rPr lang="en-US" dirty="0" smtClean="0"/>
+              <a:t>Controller Hardware</a:t>
             </a:r>
             <a:endParaRPr lang="en-US" dirty="0"/>
           </a:p>
@@ -3225,7 +3473,7 @@
         <p:spPr/>
         <p:txBody>
           <a:bodyPr>
-            <a:normAutofit fontScale="92500" lnSpcReduction="20000"/>
+            <a:normAutofit fontScale="85000" lnSpcReduction="20000"/>
           </a:bodyPr>
           <a:lstStyle/>
           <a:p>
@@ -3243,6 +3491,7 @@
             </a:r>
           </a:p>
           <a:p>
+            <a:pPr lvl="1"/>
             <a:r>
               <a:rPr lang="en-US" dirty="0" err="1" smtClean="0"/>
               <a:t>RadioLink</a:t>
@@ -3255,10 +3504,44 @@
               <a:rPr lang="en-US" dirty="0" err="1" smtClean="0"/>
               <a:t>PixHawk</a:t>
             </a:r>
+            <a:r>
+              <a:rPr lang="en-US" dirty="0" smtClean="0"/>
+              <a:t> – probably best quality, but many knock-offs</a:t>
+            </a:r>
+          </a:p>
+          <a:p>
+            <a:pPr lvl="2"/>
+            <a:r>
+              <a:rPr lang="en-US" dirty="0" err="1" smtClean="0"/>
+              <a:t>RadioLink</a:t>
+            </a:r>
+            <a:r>
+              <a:rPr lang="en-US" dirty="0" smtClean="0"/>
+              <a:t> versions actually have '</a:t>
+            </a:r>
+            <a:r>
+              <a:rPr lang="en-US" dirty="0" err="1" smtClean="0"/>
+              <a:t>RadioLink</a:t>
+            </a:r>
+            <a:r>
+              <a:rPr lang="en-US" dirty="0" smtClean="0"/>
+              <a:t>' printed on them</a:t>
+            </a:r>
+          </a:p>
+          <a:p>
+            <a:pPr lvl="2"/>
+            <a:r>
+              <a:rPr lang="en-US" dirty="0" err="1" smtClean="0"/>
+              <a:t>RadioLink</a:t>
+            </a:r>
+            <a:r>
+              <a:rPr lang="en-US" dirty="0" smtClean="0"/>
+              <a:t> version works with </a:t>
+            </a:r>
             <a:endParaRPr lang="en-US" dirty="0" smtClean="0"/>
           </a:p>
           <a:p>
-            <a:pPr lvl="1"/>
+            <a:pPr lvl="2"/>
             <a:r>
               <a:rPr lang="en-US" dirty="0" err="1" smtClean="0"/>
               <a:t>Predessor</a:t>
@@ -3457,9 +3740,22 @@
           <a:p>
             <a:pPr lvl="1"/>
             <a:r>
+              <a:rPr lang="en-US" dirty="0"/>
+              <a:t>Receiver / </a:t>
+            </a:r>
+            <a:r>
+              <a:rPr lang="en-US" dirty="0" smtClean="0"/>
+              <a:t>Antenna</a:t>
+            </a:r>
+            <a:endParaRPr lang="en-US" dirty="0" smtClean="0"/>
+          </a:p>
+          <a:p>
+            <a:pPr lvl="1"/>
+            <a:r>
               <a:rPr lang="en-US" dirty="0" smtClean="0"/>
               <a:t>Servos</a:t>
             </a:r>
+            <a:endParaRPr lang="en-US" dirty="0" smtClean="0"/>
           </a:p>
           <a:p>
             <a:pPr lvl="1"/>
@@ -3494,53 +3790,46 @@
             <a:pPr lvl="1"/>
             <a:r>
               <a:rPr lang="en-US" dirty="0" smtClean="0"/>
-              <a:t>Receiver / Antenna</a:t>
+              <a:t>IMU </a:t>
+            </a:r>
+            <a:r>
+              <a:rPr lang="en-US" dirty="0" smtClean="0"/>
+              <a:t>(Inertial Measurement Units): accelerometers / gyroscopes / magnetometers</a:t>
             </a:r>
           </a:p>
           <a:p>
             <a:pPr lvl="1"/>
             <a:r>
               <a:rPr lang="en-US" dirty="0" smtClean="0"/>
-              <a:t>IMU (Inertial Measurement Units): accelerometers / gyroscopes / magnetometers</a:t>
+              <a:t>Altitude: Barometer</a:t>
             </a:r>
           </a:p>
           <a:p>
             <a:pPr lvl="1"/>
             <a:r>
               <a:rPr lang="en-US" dirty="0" smtClean="0"/>
-              <a:t>Altitude: Barometer</a:t>
+              <a:t>Air speed sensor</a:t>
             </a:r>
           </a:p>
           <a:p>
             <a:pPr lvl="1"/>
             <a:r>
               <a:rPr lang="en-US" dirty="0" smtClean="0"/>
-              <a:t>Air speed sensor</a:t>
+              <a:t>Camera</a:t>
             </a:r>
           </a:p>
           <a:p>
             <a:pPr lvl="1"/>
             <a:r>
               <a:rPr lang="en-US" dirty="0" smtClean="0"/>
-              <a:t>Camera</a:t>
+              <a:t>Lidar</a:t>
             </a:r>
           </a:p>
           <a:p>
             <a:pPr lvl="1"/>
             <a:r>
               <a:rPr lang="en-US" dirty="0" smtClean="0"/>
-              <a:t>Lidar</a:t>
-            </a:r>
-          </a:p>
-          <a:p>
-            <a:pPr lvl="1"/>
-            <a:r>
-              <a:rPr lang="en-US" dirty="0" smtClean="0"/>
-              <a:t>Buzzer for </a:t>
-            </a:r>
-            <a:r>
-              <a:rPr lang="en-US" dirty="0" smtClean="0"/>
-              <a:t>feedback</a:t>
+              <a:t>Buzzer for feedback</a:t>
             </a:r>
           </a:p>
           <a:p>
@@ -3556,11 +3845,59 @@
               <a:rPr lang="en-US" dirty="0" smtClean="0"/>
               <a:t> cable and hit ‘Connect’ button from Mission Planner</a:t>
             </a:r>
-            <a:endParaRPr lang="en-US" dirty="0" smtClean="0"/>
           </a:p>
           <a:p>
             <a:pPr lvl="1"/>
             <a:endParaRPr lang="en-US" dirty="0" smtClean="0"/>
+          </a:p>
+        </p:txBody>
+      </p:sp>
+      <p:sp>
+        <p:nvSpPr>
+          <p:cNvPr id="4" name="Rectangle 3"/>
+          <p:cNvSpPr/>
+          <p:nvPr/>
+        </p:nvSpPr>
+        <p:spPr>
+          <a:xfrm>
+            <a:off x="4320514" y="3244334"/>
+            <a:ext cx="3550972" cy="369332"/>
+          </a:xfrm>
+          <a:prstGeom prst="rect">
+            <a:avLst/>
+          </a:prstGeom>
+        </p:spPr>
+        <p:txBody>
+          <a:bodyPr wrap="none">
+            <a:spAutoFit/>
+          </a:bodyPr>
+          <a:lstStyle/>
+          <a:p>
+            <a:r>
+              <a:rPr lang="en-US" dirty="0">
+                <a:solidFill>
+                  <a:srgbClr val="000000"/>
+                </a:solidFill>
+                <a:highlight>
+                  <a:srgbClr val="FFFFFF"/>
+                </a:highlight>
+                <a:latin typeface="Cascadia Mono" panose="020B0609020000020004" pitchFamily="49" charset="0"/>
+              </a:rPr>
+              <a:t> &amp;&amp; </a:t>
+            </a:r>
+            <a:r>
+              <a:rPr lang="en-US" dirty="0" err="1">
+                <a:solidFill>
+                  <a:srgbClr val="000000"/>
+                </a:solidFill>
+                <a:highlight>
+                  <a:srgbClr val="FFFFFF"/>
+                </a:highlight>
+                <a:latin typeface="Cascadia Mono" panose="020B0609020000020004" pitchFamily="49" charset="0"/>
+              </a:rPr>
+              <a:t>sshclient.IsConnected</a:t>
+            </a:r>
+            <a:endParaRPr lang="en-US" dirty="0"/>
           </a:p>
         </p:txBody>
       </p:sp>
@@ -3578,6 +3915,248 @@
 </file>
 
 <file path=ppt/slides/slide5.xml><?xml version="1.0" encoding="utf-8"?>
+<p:sld xmlns:a="http://schemas.openxmlformats.org/drawingml/2006/main" xmlns:r="http://schemas.openxmlformats.org/officeDocument/2006/relationships" xmlns:p="http://schemas.openxmlformats.org/presentationml/2006/main">
+  <p:cSld>
+    <p:spTree>
+      <p:nvGrpSpPr>
+        <p:cNvPr id="1" name=""/>
+        <p:cNvGrpSpPr/>
+        <p:nvPr/>
+      </p:nvGrpSpPr>
+      <p:grpSpPr>
+        <a:xfrm>
+          <a:off x="0" y="0"/>
+          <a:ext cx="0" cy="0"/>
+          <a:chOff x="0" y="0"/>
+          <a:chExt cx="0" cy="0"/>
+        </a:xfrm>
+      </p:grpSpPr>
+      <p:sp>
+        <p:nvSpPr>
+          <p:cNvPr id="2" name="Title 1"/>
+          <p:cNvSpPr>
+            <a:spLocks noGrp="1"/>
+          </p:cNvSpPr>
+          <p:nvPr>
+            <p:ph type="title"/>
+          </p:nvPr>
+        </p:nvSpPr>
+        <p:spPr/>
+        <p:txBody>
+          <a:bodyPr>
+            <a:normAutofit/>
+          </a:bodyPr>
+          <a:lstStyle/>
+          <a:p>
+            <a:pPr algn="ctr"/>
+            <a:r>
+              <a:rPr lang="en-US" sz="4000" dirty="0" smtClean="0"/>
+              <a:t>Alternative to using </a:t>
+            </a:r>
+            <a:r>
+              <a:rPr lang="en-US" sz="4000" dirty="0" err="1" smtClean="0"/>
+              <a:t>MissionPlanner</a:t>
+            </a:r>
+            <a:r>
+              <a:rPr lang="en-US" sz="4000" dirty="0" smtClean="0"/>
+              <a:t> on Pi</a:t>
+            </a:r>
+            <a:br>
+              <a:rPr lang="en-US" sz="4000" dirty="0" smtClean="0"/>
+            </a:br>
+            <a:r>
+              <a:rPr lang="en-US" sz="4000" dirty="0" smtClean="0"/>
+              <a:t>to just get telemetry data from </a:t>
+            </a:r>
+            <a:r>
+              <a:rPr lang="en-US" sz="4000" dirty="0" err="1" smtClean="0"/>
+              <a:t>PixHawk</a:t>
+            </a:r>
+            <a:endParaRPr lang="en-US" sz="4000" dirty="0"/>
+          </a:p>
+        </p:txBody>
+      </p:sp>
+      <p:sp>
+        <p:nvSpPr>
+          <p:cNvPr id="3" name="Content Placeholder 2"/>
+          <p:cNvSpPr>
+            <a:spLocks noGrp="1"/>
+          </p:cNvSpPr>
+          <p:nvPr>
+            <p:ph idx="1"/>
+          </p:nvPr>
+        </p:nvSpPr>
+        <p:spPr/>
+        <p:txBody>
+          <a:bodyPr>
+            <a:normAutofit fontScale="92500" lnSpcReduction="20000"/>
+          </a:bodyPr>
+          <a:lstStyle/>
+          <a:p>
+            <a:r>
+              <a:rPr lang="en-US" dirty="0" smtClean="0"/>
+              <a:t>You can get telemetry data directly through the serial port on the </a:t>
+            </a:r>
+            <a:r>
+              <a:rPr lang="en-US" dirty="0" err="1" smtClean="0"/>
+              <a:t>PixHawk</a:t>
+            </a:r>
+            <a:endParaRPr lang="en-US" dirty="0" smtClean="0"/>
+          </a:p>
+          <a:p>
+            <a:pPr lvl="1"/>
+            <a:r>
+              <a:rPr lang="en-US" dirty="0" smtClean="0"/>
+              <a:t>this works with the </a:t>
+            </a:r>
+            <a:r>
+              <a:rPr lang="en-US" dirty="0" err="1" smtClean="0"/>
+              <a:t>RadioLink</a:t>
+            </a:r>
+            <a:r>
+              <a:rPr lang="en-US" dirty="0" smtClean="0"/>
+              <a:t> </a:t>
+            </a:r>
+            <a:r>
+              <a:rPr lang="en-US" dirty="0" err="1" smtClean="0"/>
+              <a:t>PixHawk</a:t>
+            </a:r>
+            <a:r>
+              <a:rPr lang="en-US" dirty="0" smtClean="0"/>
+              <a:t> but maybe not with knock-offs</a:t>
+            </a:r>
+          </a:p>
+          <a:p>
+            <a:r>
+              <a:rPr lang="en-US" dirty="0" smtClean="0"/>
+              <a:t>Use </a:t>
+            </a:r>
+            <a:r>
+              <a:rPr lang="en-US" dirty="0" err="1" smtClean="0"/>
+              <a:t>DroneKit</a:t>
+            </a:r>
+            <a:r>
+              <a:rPr lang="en-US" dirty="0" smtClean="0"/>
+              <a:t> python library to connect to </a:t>
+            </a:r>
+            <a:r>
+              <a:rPr lang="en-US" dirty="0" err="1" smtClean="0"/>
+              <a:t>PixHawk</a:t>
+            </a:r>
+            <a:r>
+              <a:rPr lang="en-US" dirty="0" smtClean="0"/>
+              <a:t> &amp; interpret data</a:t>
+            </a:r>
+          </a:p>
+          <a:p>
+            <a:pPr lvl="1"/>
+            <a:r>
+              <a:rPr lang="en-US" dirty="0" err="1" smtClean="0"/>
+              <a:t>DroneKit</a:t>
+            </a:r>
+            <a:r>
+              <a:rPr lang="en-US" dirty="0" smtClean="0"/>
+              <a:t> </a:t>
+            </a:r>
+            <a:r>
+              <a:rPr lang="en-US" dirty="0" err="1" smtClean="0"/>
+              <a:t>github</a:t>
+            </a:r>
+            <a:r>
+              <a:rPr lang="en-US" dirty="0" smtClean="0"/>
+              <a:t>: </a:t>
+            </a:r>
+          </a:p>
+          <a:p>
+            <a:pPr lvl="1"/>
+            <a:r>
+              <a:rPr lang="en-US" dirty="0"/>
+              <a:t>My </a:t>
+            </a:r>
+            <a:r>
+              <a:rPr lang="en-US" dirty="0" smtClean="0"/>
+              <a:t>version: </a:t>
+            </a:r>
+            <a:r>
+              <a:rPr lang="en-US" dirty="0"/>
+              <a:t>C:\</a:t>
+            </a:r>
+            <a:r>
+              <a:rPr lang="en-US" dirty="0" smtClean="0"/>
+              <a:t>p\embedded\RaspberryPi\PixHawk\dronekit_joes</a:t>
+            </a:r>
+          </a:p>
+          <a:p>
+            <a:pPr lvl="2"/>
+            <a:r>
+              <a:rPr lang="en-US" dirty="0" smtClean="0"/>
+              <a:t>dronekit_check_attitude.py just continually gets telemetry data</a:t>
+            </a:r>
+          </a:p>
+          <a:p>
+            <a:r>
+              <a:rPr lang="en-US" dirty="0" smtClean="0"/>
+              <a:t>Types of telemetry data you can get:</a:t>
+            </a:r>
+          </a:p>
+          <a:p>
+            <a:pPr lvl="1"/>
+            <a:r>
+              <a:rPr lang="en-US" dirty="0" smtClean="0"/>
+              <a:t>GPS location</a:t>
+            </a:r>
+          </a:p>
+          <a:p>
+            <a:pPr lvl="1"/>
+            <a:r>
+              <a:rPr lang="en-US" dirty="0" smtClean="0"/>
+              <a:t>Battery percent</a:t>
+            </a:r>
+          </a:p>
+          <a:p>
+            <a:pPr lvl="1"/>
+            <a:r>
+              <a:rPr lang="en-US" dirty="0" smtClean="0"/>
+              <a:t>Attitude: roll, pitch and yaw</a:t>
+            </a:r>
+          </a:p>
+          <a:p>
+            <a:pPr lvl="1"/>
+            <a:r>
+              <a:rPr lang="en-US" dirty="0" smtClean="0"/>
+              <a:t>Velocity / Ground speed / Air speed</a:t>
+            </a:r>
+          </a:p>
+          <a:p>
+            <a:pPr lvl="1"/>
+            <a:r>
+              <a:rPr lang="en-US" dirty="0" smtClean="0"/>
+              <a:t>Gimbal status</a:t>
+            </a:r>
+          </a:p>
+          <a:p>
+            <a:pPr lvl="1"/>
+            <a:r>
+              <a:rPr lang="en-US" dirty="0" smtClean="0"/>
+              <a:t>Armed yes/no</a:t>
+            </a:r>
+          </a:p>
+        </p:txBody>
+      </p:sp>
+    </p:spTree>
+    <p:extLst>
+      <p:ext uri="{BB962C8B-B14F-4D97-AF65-F5344CB8AC3E}">
+        <p14:creationId xmlns:p14="http://schemas.microsoft.com/office/powerpoint/2010/main" val="1570517125"/>
+      </p:ext>
+    </p:extLst>
+  </p:cSld>
+  <p:clrMapOvr>
+    <a:masterClrMapping/>
+  </p:clrMapOvr>
+</p:sld>
+</file>
+
+<file path=ppt/slides/slide6.xml><?xml version="1.0" encoding="utf-8"?>
 <p:sld xmlns:a="http://schemas.openxmlformats.org/drawingml/2006/main" xmlns:r="http://schemas.openxmlformats.org/officeDocument/2006/relationships" xmlns:p="http://schemas.openxmlformats.org/presentationml/2006/main">
   <p:cSld>
     <p:spTree>
@@ -4066,135 +4645,6 @@
 </p:sld>
 </file>
 
-<file path=ppt/slides/slide6.xml><?xml version="1.0" encoding="utf-8"?>
-<p:sld xmlns:a="http://schemas.openxmlformats.org/drawingml/2006/main" xmlns:r="http://schemas.openxmlformats.org/officeDocument/2006/relationships" xmlns:p="http://schemas.openxmlformats.org/presentationml/2006/main">
-  <p:cSld>
-    <p:spTree>
-      <p:nvGrpSpPr>
-        <p:cNvPr id="1" name=""/>
-        <p:cNvGrpSpPr/>
-        <p:nvPr/>
-      </p:nvGrpSpPr>
-      <p:grpSpPr>
-        <a:xfrm>
-          <a:off x="0" y="0"/>
-          <a:ext cx="0" cy="0"/>
-          <a:chOff x="0" y="0"/>
-          <a:chExt cx="0" cy="0"/>
-        </a:xfrm>
-      </p:grpSpPr>
-      <p:sp>
-        <p:nvSpPr>
-          <p:cNvPr id="2" name="Title 1"/>
-          <p:cNvSpPr>
-            <a:spLocks noGrp="1"/>
-          </p:cNvSpPr>
-          <p:nvPr>
-            <p:ph type="title"/>
-          </p:nvPr>
-        </p:nvSpPr>
-        <p:spPr/>
-        <p:txBody>
-          <a:bodyPr/>
-          <a:lstStyle/>
-          <a:p>
-            <a:pPr algn="ctr"/>
-            <a:r>
-              <a:rPr lang="en-US" dirty="0" err="1" smtClean="0"/>
-              <a:t>CubePilot</a:t>
-            </a:r>
-            <a:r>
-              <a:rPr lang="en-US" dirty="0" smtClean="0"/>
-              <a:t> Cube</a:t>
-            </a:r>
-            <a:endParaRPr lang="en-US" dirty="0"/>
-          </a:p>
-        </p:txBody>
-      </p:sp>
-      <p:sp>
-        <p:nvSpPr>
-          <p:cNvPr id="3" name="Content Placeholder 2"/>
-          <p:cNvSpPr>
-            <a:spLocks noGrp="1"/>
-          </p:cNvSpPr>
-          <p:nvPr>
-            <p:ph idx="1"/>
-          </p:nvPr>
-        </p:nvSpPr>
-        <p:spPr/>
-        <p:txBody>
-          <a:bodyPr/>
-          <a:lstStyle/>
-          <a:p>
-            <a:r>
-              <a:rPr lang="en-US" dirty="0" smtClean="0"/>
-              <a:t>Cube plugs into something that looks like </a:t>
-            </a:r>
-            <a:r>
-              <a:rPr lang="en-US" dirty="0" err="1" smtClean="0"/>
-              <a:t>PixHawk</a:t>
-            </a:r>
-            <a:r>
-              <a:rPr lang="en-US" dirty="0" smtClean="0"/>
-              <a:t> but actually says </a:t>
-            </a:r>
-            <a:r>
-              <a:rPr lang="en-US" dirty="0" err="1" smtClean="0"/>
-              <a:t>CubePilot</a:t>
-            </a:r>
-            <a:r>
-              <a:rPr lang="en-US" dirty="0" smtClean="0"/>
-              <a:t> on it as well</a:t>
-            </a:r>
-          </a:p>
-          <a:p>
-            <a:r>
-              <a:rPr lang="en-US" dirty="0" smtClean="0"/>
-              <a:t>Orange+ is latest &amp; greatest $350</a:t>
-            </a:r>
-          </a:p>
-          <a:p>
-            <a:pPr lvl="1"/>
-            <a:r>
-              <a:rPr lang="en-US" dirty="0" smtClean="0"/>
-              <a:t>Cheaper mini purple version for ground vehicles</a:t>
-            </a:r>
-          </a:p>
-          <a:p>
-            <a:r>
-              <a:rPr lang="en-US" dirty="0" smtClean="0"/>
-              <a:t>Original version of Cube was black and called a ‘</a:t>
-            </a:r>
-            <a:r>
-              <a:rPr lang="en-US" dirty="0" err="1" smtClean="0"/>
-              <a:t>PixHawk</a:t>
-            </a:r>
-            <a:r>
-              <a:rPr lang="en-US" dirty="0" smtClean="0"/>
-              <a:t> 2.1’ but the named changed to just ‘Cube’</a:t>
-            </a:r>
-          </a:p>
-          <a:p>
-            <a:endParaRPr lang="en-US" dirty="0" smtClean="0"/>
-          </a:p>
-          <a:p>
-            <a:endParaRPr lang="en-US" dirty="0"/>
-          </a:p>
-        </p:txBody>
-      </p:sp>
-    </p:spTree>
-    <p:extLst>
-      <p:ext uri="{BB962C8B-B14F-4D97-AF65-F5344CB8AC3E}">
-        <p14:creationId xmlns:p14="http://schemas.microsoft.com/office/powerpoint/2010/main" val="117938741"/>
-      </p:ext>
-    </p:extLst>
-  </p:cSld>
-  <p:clrMapOvr>
-    <a:masterClrMapping/>
-  </p:clrMapOvr>
-</p:sld>
-</file>
-
 <file path=ppt/slides/slide7.xml><?xml version="1.0" encoding="utf-8"?>
 <p:sld xmlns:a="http://schemas.openxmlformats.org/drawingml/2006/main" xmlns:r="http://schemas.openxmlformats.org/officeDocument/2006/relationships" xmlns:p="http://schemas.openxmlformats.org/presentationml/2006/main">
   <p:cSld>
@@ -4222,77 +4672,78 @@
             <p:ph type="title"/>
           </p:nvPr>
         </p:nvSpPr>
-        <p:spPr>
-          <a:xfrm>
-            <a:off x="838201" y="365125"/>
-            <a:ext cx="1386254" cy="5472967"/>
-          </a:xfrm>
-        </p:spPr>
+        <p:spPr/>
         <p:txBody>
           <a:bodyPr>
-            <a:normAutofit/>
+            <a:normAutofit fontScale="90000"/>
           </a:bodyPr>
           <a:lstStyle/>
           <a:p>
-            <a:r>
-              <a:rPr lang="en-US" sz="2400" dirty="0" err="1" smtClean="0"/>
-              <a:t>CubePilot</a:t>
-            </a:r>
-            <a:r>
-              <a:rPr lang="en-US" sz="2400" dirty="0" smtClean="0"/>
-              <a:t> Cube Orange+</a:t>
-            </a:r>
-            <a:endParaRPr lang="en-US" sz="2400" dirty="0"/>
+            <a:pPr algn="ctr"/>
+            <a:r>
+              <a:rPr lang="en-US" dirty="0" smtClean="0"/>
+              <a:t>Power Adapter so </a:t>
+            </a:r>
+            <a:r>
+              <a:rPr lang="en-US" dirty="0" err="1" smtClean="0"/>
+              <a:t>Lipo</a:t>
+            </a:r>
+            <a:r>
+              <a:rPr lang="en-US" dirty="0" smtClean="0"/>
+              <a:t> battery can power the </a:t>
+            </a:r>
+            <a:r>
+              <a:rPr lang="en-US" dirty="0" err="1" smtClean="0"/>
+              <a:t>PixHawk</a:t>
+            </a:r>
+            <a:r>
+              <a:rPr lang="en-US" dirty="0" smtClean="0"/>
+              <a:t> as well as the motors</a:t>
+            </a:r>
+            <a:br>
+              <a:rPr lang="en-US" dirty="0" smtClean="0"/>
+            </a:br>
+            <a:r>
+              <a:rPr lang="en-US" sz="3100" dirty="0" smtClean="0"/>
+              <a:t>(also available in XT60 style plug)</a:t>
+            </a:r>
+            <a:endParaRPr lang="en-US" dirty="0"/>
           </a:p>
         </p:txBody>
       </p:sp>
       <p:pic>
         <p:nvPicPr>
-          <p:cNvPr id="1026" name="Picture 2" descr="https://discuss.ardupilot.org/uploads/default/original/3X/0/b/0b28377ded225ec3c485b9342cb86fb1ff5a5c22.jpeg"/>
+          <p:cNvPr id="4" name="Content Placeholder 3"/>
           <p:cNvPicPr>
-            <a:picLocks noGrp="1" noChangeAspect="1" noChangeArrowheads="1"/>
+            <a:picLocks noGrp="1" noChangeAspect="1"/>
           </p:cNvPicPr>
           <p:nvPr>
             <p:ph idx="1"/>
           </p:nvPr>
         </p:nvPicPr>
         <p:blipFill>
-          <a:blip r:embed="rId2" cstate="print">
+          <a:blip r:embed="rId2">
             <a:extLst>
               <a:ext uri="{28A0092B-C50C-407E-A947-70E740481C1C}">
                 <a14:useLocalDpi xmlns:a14="http://schemas.microsoft.com/office/drawing/2010/main" val="0"/>
               </a:ext>
             </a:extLst>
           </a:blip>
-          <a:srcRect/>
           <a:stretch>
             <a:fillRect/>
           </a:stretch>
         </p:blipFill>
-        <p:spPr bwMode="auto">
+        <p:spPr>
           <a:xfrm>
-            <a:off x="3077308" y="2746"/>
-            <a:ext cx="5169877" cy="6893171"/>
+            <a:off x="2753969" y="1825625"/>
+            <a:ext cx="6684061" cy="4351338"/>
           </a:xfrm>
-          <a:prstGeom prst="rect">
-            <a:avLst/>
-          </a:prstGeom>
-          <a:noFill/>
-          <a:extLst>
-            <a:ext uri="{909E8E84-426E-40DD-AFC4-6F175D3DCCD1}">
-              <a14:hiddenFill xmlns:a14="http://schemas.microsoft.com/office/drawing/2010/main">
-                <a:solidFill>
-                  <a:srgbClr val="FFFFFF"/>
-                </a:solidFill>
-              </a14:hiddenFill>
-            </a:ext>
-          </a:extLst>
         </p:spPr>
       </p:pic>
     </p:spTree>
     <p:extLst>
       <p:ext uri="{BB962C8B-B14F-4D97-AF65-F5344CB8AC3E}">
-        <p14:creationId xmlns:p14="http://schemas.microsoft.com/office/powerpoint/2010/main" val="3806912843"/>
+        <p14:creationId xmlns:p14="http://schemas.microsoft.com/office/powerpoint/2010/main" val="2839689198"/>
       </p:ext>
     </p:extLst>
   </p:cSld>
@@ -4334,91 +4785,334 @@
           <a:bodyPr/>
           <a:lstStyle/>
           <a:p>
-            <a:r>
-              <a:rPr lang="en-US" dirty="0" smtClean="0"/>
-              <a:t>Ground Control Software</a:t>
+            <a:pPr algn="ctr"/>
+            <a:r>
+              <a:rPr lang="en-US" dirty="0" err="1" smtClean="0"/>
+              <a:t>PixHawk</a:t>
+            </a:r>
+            <a:r>
+              <a:rPr lang="en-US" dirty="0" smtClean="0"/>
+              <a:t> accessories</a:t>
             </a:r>
             <a:endParaRPr lang="en-US" dirty="0"/>
           </a:p>
         </p:txBody>
       </p:sp>
-      <p:sp>
-        <p:nvSpPr>
-          <p:cNvPr id="3" name="Content Placeholder 2"/>
-          <p:cNvSpPr>
-            <a:spLocks noGrp="1"/>
-          </p:cNvSpPr>
+      <p:pic>
+        <p:nvPicPr>
+          <p:cNvPr id="4" name="Content Placeholder 3"/>
+          <p:cNvPicPr>
+            <a:picLocks noGrp="1" noChangeAspect="1"/>
+          </p:cNvPicPr>
           <p:nvPr>
             <p:ph idx="1"/>
           </p:nvPr>
-        </p:nvSpPr>
-        <p:spPr/>
-        <p:txBody>
-          <a:bodyPr/>
-          <a:lstStyle/>
-          <a:p>
-            <a:r>
-              <a:rPr lang="en-US" dirty="0" smtClean="0"/>
-              <a:t>Mission Planner is most popular and easiest, but also:</a:t>
-            </a:r>
-          </a:p>
-          <a:p>
-            <a:pPr lvl="2"/>
+        </p:nvPicPr>
+        <p:blipFill>
+          <a:blip r:embed="rId2">
+            <a:extLst>
+              <a:ext uri="{28A0092B-C50C-407E-A947-70E740481C1C}">
+                <a14:useLocalDpi xmlns:a14="http://schemas.microsoft.com/office/drawing/2010/main" val="0"/>
+              </a:ext>
+            </a:extLst>
+          </a:blip>
+          <a:stretch>
+            <a:fillRect/>
+          </a:stretch>
+        </p:blipFill>
+        <p:spPr>
+          <a:xfrm>
+            <a:off x="3727839" y="1825625"/>
+            <a:ext cx="4736322" cy="4351338"/>
+          </a:xfrm>
+        </p:spPr>
+      </p:pic>
+      <p:sp>
+        <p:nvSpPr>
+          <p:cNvPr id="5" name="TextBox 4"/>
+          <p:cNvSpPr txBox="1"/>
+          <p:nvPr/>
+        </p:nvSpPr>
+        <p:spPr>
+          <a:xfrm>
+            <a:off x="8779042" y="1660358"/>
+            <a:ext cx="3353290" cy="1200329"/>
+          </a:xfrm>
+          <a:prstGeom prst="rect">
+            <a:avLst/>
+          </a:prstGeom>
+          <a:noFill/>
+        </p:spPr>
+        <p:txBody>
+          <a:bodyPr wrap="none" rtlCol="0">
+            <a:spAutoFit/>
+          </a:bodyPr>
+          <a:lstStyle/>
+          <a:p>
+            <a:r>
+              <a:rPr lang="en-US" dirty="0" smtClean="0"/>
+              <a:t>6-pin connector adapter, can also</a:t>
+            </a:r>
+          </a:p>
+          <a:p>
+            <a:r>
+              <a:rPr lang="en-US" dirty="0" smtClean="0"/>
+              <a:t>get version that splits into single</a:t>
+            </a:r>
+          </a:p>
+          <a:p>
+            <a:r>
+              <a:rPr lang="en-US" dirty="0" smtClean="0"/>
+              <a:t>wires to hookup serial connection</a:t>
+            </a:r>
+          </a:p>
+          <a:p>
+            <a:r>
+              <a:rPr lang="en-US" dirty="0" smtClean="0"/>
+              <a:t>to Pi or </a:t>
+            </a:r>
             <a:r>
               <a:rPr lang="en-US" dirty="0" err="1" smtClean="0"/>
-              <a:t>QGroundControl</a:t>
-            </a:r>
-            <a:endParaRPr lang="en-US" dirty="0" smtClean="0"/>
-          </a:p>
-          <a:p>
-            <a:pPr lvl="2"/>
-            <a:r>
-              <a:rPr lang="en-US" dirty="0" smtClean="0"/>
-              <a:t>APM Planner 2</a:t>
-            </a:r>
-          </a:p>
-          <a:p>
-            <a:pPr lvl="2"/>
-            <a:r>
-              <a:rPr lang="en-US" dirty="0" smtClean="0"/>
-              <a:t>could also run app from phone or tablet</a:t>
-            </a:r>
-          </a:p>
-          <a:p>
-            <a:r>
-              <a:rPr lang="en-US" dirty="0" smtClean="0"/>
-              <a:t>Used to flash firmware onto the flight controller hardware</a:t>
-            </a:r>
-          </a:p>
-          <a:p>
-            <a:r>
-              <a:rPr lang="en-US" dirty="0" smtClean="0"/>
-              <a:t>Used to monitor flight and control vehicle remotely</a:t>
-            </a:r>
-          </a:p>
-          <a:p>
-            <a:pPr lvl="1"/>
-            <a:r>
-              <a:rPr lang="en-US" dirty="0" smtClean="0"/>
-              <a:t>Can use in combination with a joystick-type controller, but it’s possible to have no controller at all. The point is an autonomous flight plan, anyways.</a:t>
-            </a:r>
-          </a:p>
-          <a:p>
-            <a:pPr lvl="1"/>
-            <a:r>
-              <a:rPr lang="en-US" dirty="0" smtClean="0"/>
-              <a:t>Can stop the flight and call back </a:t>
-            </a:r>
-            <a:r>
-              <a:rPr lang="en-US" smtClean="0"/>
-              <a:t>to home, etc.</a:t>
-            </a:r>
-            <a:endParaRPr lang="en-US" dirty="0" smtClean="0"/>
-          </a:p>
-          <a:p>
-            <a:endParaRPr lang="en-US" dirty="0" smtClean="0"/>
-          </a:p>
-          <a:p>
+              <a:t>Nvidia</a:t>
+            </a:r>
+            <a:r>
+              <a:rPr lang="en-US" dirty="0" smtClean="0"/>
+              <a:t> Nano.</a:t>
+            </a:r>
+            <a:endParaRPr lang="en-US" dirty="0"/>
+          </a:p>
+        </p:txBody>
+      </p:sp>
+      <p:cxnSp>
+        <p:nvCxnSpPr>
+          <p:cNvPr id="7" name="Straight Arrow Connector 6"/>
+          <p:cNvCxnSpPr/>
+          <p:nvPr/>
+        </p:nvCxnSpPr>
+        <p:spPr>
+          <a:xfrm flipV="1">
+            <a:off x="7924800" y="1925053"/>
+            <a:ext cx="854242" cy="533399"/>
+          </a:xfrm>
+          <a:prstGeom prst="straightConnector1">
+            <a:avLst/>
+          </a:prstGeom>
+          <a:ln>
+            <a:tailEnd type="triangle"/>
+          </a:ln>
+        </p:spPr>
+        <p:style>
+          <a:lnRef idx="1">
+            <a:schemeClr val="accent1"/>
+          </a:lnRef>
+          <a:fillRef idx="0">
+            <a:schemeClr val="accent1"/>
+          </a:fillRef>
+          <a:effectRef idx="0">
+            <a:schemeClr val="accent1"/>
+          </a:effectRef>
+          <a:fontRef idx="minor">
+            <a:schemeClr val="tx1"/>
+          </a:fontRef>
+        </p:style>
+      </p:cxnSp>
+      <p:cxnSp>
+        <p:nvCxnSpPr>
+          <p:cNvPr id="9" name="Straight Arrow Connector 8"/>
+          <p:cNvCxnSpPr/>
+          <p:nvPr/>
+        </p:nvCxnSpPr>
+        <p:spPr>
+          <a:xfrm flipH="1" flipV="1">
+            <a:off x="3034993" y="4840705"/>
+            <a:ext cx="855218" cy="348290"/>
+          </a:xfrm>
+          <a:prstGeom prst="straightConnector1">
+            <a:avLst/>
+          </a:prstGeom>
+          <a:ln>
+            <a:tailEnd type="triangle"/>
+          </a:ln>
+        </p:spPr>
+        <p:style>
+          <a:lnRef idx="1">
+            <a:schemeClr val="accent1"/>
+          </a:lnRef>
+          <a:fillRef idx="0">
+            <a:schemeClr val="accent1"/>
+          </a:fillRef>
+          <a:effectRef idx="0">
+            <a:schemeClr val="accent1"/>
+          </a:effectRef>
+          <a:fontRef idx="minor">
+            <a:schemeClr val="tx1"/>
+          </a:fontRef>
+        </p:style>
+      </p:cxnSp>
+      <p:sp>
+        <p:nvSpPr>
+          <p:cNvPr id="10" name="TextBox 9"/>
+          <p:cNvSpPr txBox="1"/>
+          <p:nvPr/>
+        </p:nvSpPr>
+        <p:spPr>
+          <a:xfrm>
+            <a:off x="597304" y="4517539"/>
+            <a:ext cx="3095912" cy="646331"/>
+          </a:xfrm>
+          <a:prstGeom prst="rect">
+            <a:avLst/>
+          </a:prstGeom>
+          <a:noFill/>
+        </p:spPr>
+        <p:txBody>
+          <a:bodyPr wrap="none" rtlCol="0">
+            <a:spAutoFit/>
+          </a:bodyPr>
+          <a:lstStyle/>
+          <a:p>
+            <a:r>
+              <a:rPr lang="en-US" dirty="0" smtClean="0"/>
+              <a:t>Buzzer for audio feedback such</a:t>
+            </a:r>
+          </a:p>
+          <a:p>
+            <a:r>
+              <a:rPr lang="en-US" dirty="0" smtClean="0"/>
+              <a:t>as when it’s 'armed'.</a:t>
+            </a:r>
+            <a:endParaRPr lang="en-US" dirty="0"/>
+          </a:p>
+        </p:txBody>
+      </p:sp>
+      <p:cxnSp>
+        <p:nvCxnSpPr>
+          <p:cNvPr id="11" name="Straight Arrow Connector 10"/>
+          <p:cNvCxnSpPr/>
+          <p:nvPr/>
+        </p:nvCxnSpPr>
+        <p:spPr>
+          <a:xfrm flipH="1" flipV="1">
+            <a:off x="3529263" y="3400927"/>
+            <a:ext cx="2318085" cy="800099"/>
+          </a:xfrm>
+          <a:prstGeom prst="straightConnector1">
+            <a:avLst/>
+          </a:prstGeom>
+          <a:ln>
+            <a:tailEnd type="triangle"/>
+          </a:ln>
+        </p:spPr>
+        <p:style>
+          <a:lnRef idx="1">
+            <a:schemeClr val="accent1"/>
+          </a:lnRef>
+          <a:fillRef idx="0">
+            <a:schemeClr val="accent1"/>
+          </a:fillRef>
+          <a:effectRef idx="0">
+            <a:schemeClr val="accent1"/>
+          </a:effectRef>
+          <a:fontRef idx="minor">
+            <a:schemeClr val="tx1"/>
+          </a:fontRef>
+        </p:style>
+      </p:cxnSp>
+      <p:sp>
+        <p:nvSpPr>
+          <p:cNvPr id="13" name="TextBox 12"/>
+          <p:cNvSpPr txBox="1"/>
+          <p:nvPr/>
+        </p:nvSpPr>
+        <p:spPr>
+          <a:xfrm>
+            <a:off x="1081221" y="3154645"/>
+            <a:ext cx="2577372" cy="646331"/>
+          </a:xfrm>
+          <a:prstGeom prst="rect">
+            <a:avLst/>
+          </a:prstGeom>
+          <a:noFill/>
+        </p:spPr>
+        <p:txBody>
+          <a:bodyPr wrap="none" rtlCol="0">
+            <a:spAutoFit/>
+          </a:bodyPr>
+          <a:lstStyle/>
+          <a:p>
+            <a:r>
+              <a:rPr lang="en-US" dirty="0" smtClean="0"/>
+              <a:t>Safety button to turn </a:t>
+            </a:r>
+          </a:p>
+          <a:p>
+            <a:r>
+              <a:rPr lang="en-US" dirty="0" smtClean="0"/>
+              <a:t>on/off motors or 'arm‘ it. </a:t>
+            </a:r>
+            <a:endParaRPr lang="en-US" dirty="0"/>
+          </a:p>
+        </p:txBody>
+      </p:sp>
+      <p:cxnSp>
+        <p:nvCxnSpPr>
+          <p:cNvPr id="14" name="Straight Arrow Connector 13"/>
+          <p:cNvCxnSpPr/>
+          <p:nvPr/>
+        </p:nvCxnSpPr>
+        <p:spPr>
+          <a:xfrm flipV="1">
+            <a:off x="8141369" y="4567989"/>
+            <a:ext cx="902368" cy="418654"/>
+          </a:xfrm>
+          <a:prstGeom prst="straightConnector1">
+            <a:avLst/>
+          </a:prstGeom>
+          <a:ln>
+            <a:tailEnd type="triangle"/>
+          </a:ln>
+        </p:spPr>
+        <p:style>
+          <a:lnRef idx="1">
+            <a:schemeClr val="accent1"/>
+          </a:lnRef>
+          <a:fillRef idx="0">
+            <a:schemeClr val="accent1"/>
+          </a:fillRef>
+          <a:effectRef idx="0">
+            <a:schemeClr val="accent1"/>
+          </a:effectRef>
+          <a:fontRef idx="minor">
+            <a:schemeClr val="tx1"/>
+          </a:fontRef>
+        </p:style>
+      </p:cxnSp>
+      <p:sp>
+        <p:nvSpPr>
+          <p:cNvPr id="16" name="TextBox 15"/>
+          <p:cNvSpPr txBox="1"/>
+          <p:nvPr/>
+        </p:nvSpPr>
+        <p:spPr>
+          <a:xfrm>
+            <a:off x="8995611" y="4383323"/>
+            <a:ext cx="1319272" cy="369332"/>
+          </a:xfrm>
+          <a:prstGeom prst="rect">
+            <a:avLst/>
+          </a:prstGeom>
+          <a:noFill/>
+        </p:spPr>
+        <p:txBody>
+          <a:bodyPr wrap="none" rtlCol="0">
+            <a:spAutoFit/>
+          </a:bodyPr>
+          <a:lstStyle/>
+          <a:p>
+            <a:r>
+              <a:rPr lang="en-US" dirty="0" smtClean="0"/>
+              <a:t>Servo cable.</a:t>
+            </a:r>
             <a:endParaRPr lang="en-US" dirty="0"/>
           </a:p>
         </p:txBody>
@@ -4426,7 +5120,136 @@
     </p:spTree>
     <p:extLst>
       <p:ext uri="{BB962C8B-B14F-4D97-AF65-F5344CB8AC3E}">
-        <p14:creationId xmlns:p14="http://schemas.microsoft.com/office/powerpoint/2010/main" val="4237575968"/>
+        <p14:creationId xmlns:p14="http://schemas.microsoft.com/office/powerpoint/2010/main" val="485040800"/>
+      </p:ext>
+    </p:extLst>
+  </p:cSld>
+  <p:clrMapOvr>
+    <a:masterClrMapping/>
+  </p:clrMapOvr>
+</p:sld>
+</file>
+
+<file path=ppt/slides/slide9.xml><?xml version="1.0" encoding="utf-8"?>
+<p:sld xmlns:a="http://schemas.openxmlformats.org/drawingml/2006/main" xmlns:r="http://schemas.openxmlformats.org/officeDocument/2006/relationships" xmlns:p="http://schemas.openxmlformats.org/presentationml/2006/main">
+  <p:cSld>
+    <p:spTree>
+      <p:nvGrpSpPr>
+        <p:cNvPr id="1" name=""/>
+        <p:cNvGrpSpPr/>
+        <p:nvPr/>
+      </p:nvGrpSpPr>
+      <p:grpSpPr>
+        <a:xfrm>
+          <a:off x="0" y="0"/>
+          <a:ext cx="0" cy="0"/>
+          <a:chOff x="0" y="0"/>
+          <a:chExt cx="0" cy="0"/>
+        </a:xfrm>
+      </p:grpSpPr>
+      <p:sp>
+        <p:nvSpPr>
+          <p:cNvPr id="2" name="Title 1"/>
+          <p:cNvSpPr>
+            <a:spLocks noGrp="1"/>
+          </p:cNvSpPr>
+          <p:nvPr>
+            <p:ph type="title"/>
+          </p:nvPr>
+        </p:nvSpPr>
+        <p:spPr/>
+        <p:txBody>
+          <a:bodyPr/>
+          <a:lstStyle/>
+          <a:p>
+            <a:pPr algn="ctr"/>
+            <a:r>
+              <a:rPr lang="en-US" dirty="0" err="1" smtClean="0"/>
+              <a:t>CubePilot</a:t>
+            </a:r>
+            <a:r>
+              <a:rPr lang="en-US" dirty="0" smtClean="0"/>
+              <a:t> Cube</a:t>
+            </a:r>
+            <a:endParaRPr lang="en-US" dirty="0"/>
+          </a:p>
+        </p:txBody>
+      </p:sp>
+      <p:sp>
+        <p:nvSpPr>
+          <p:cNvPr id="3" name="Content Placeholder 2"/>
+          <p:cNvSpPr>
+            <a:spLocks noGrp="1"/>
+          </p:cNvSpPr>
+          <p:nvPr>
+            <p:ph idx="1"/>
+          </p:nvPr>
+        </p:nvSpPr>
+        <p:spPr/>
+        <p:txBody>
+          <a:bodyPr/>
+          <a:lstStyle/>
+          <a:p>
+            <a:r>
+              <a:rPr lang="en-US" dirty="0" smtClean="0"/>
+              <a:t>Cube plugs into something that looks like </a:t>
+            </a:r>
+            <a:r>
+              <a:rPr lang="en-US" dirty="0" err="1" smtClean="0"/>
+              <a:t>PixHawk</a:t>
+            </a:r>
+            <a:r>
+              <a:rPr lang="en-US" dirty="0" smtClean="0"/>
+              <a:t> but actually says </a:t>
+            </a:r>
+            <a:r>
+              <a:rPr lang="en-US" dirty="0" err="1" smtClean="0"/>
+              <a:t>CubePilot</a:t>
+            </a:r>
+            <a:r>
+              <a:rPr lang="en-US" dirty="0" smtClean="0"/>
+              <a:t> on it as well</a:t>
+            </a:r>
+          </a:p>
+          <a:p>
+            <a:r>
+              <a:rPr lang="en-US" dirty="0" smtClean="0"/>
+              <a:t>Orange+ is latest &amp; greatest $350</a:t>
+            </a:r>
+          </a:p>
+          <a:p>
+            <a:pPr lvl="1"/>
+            <a:r>
+              <a:rPr lang="en-US" dirty="0" smtClean="0"/>
+              <a:t>Cheaper mini purple version for ground vehicles</a:t>
+            </a:r>
+          </a:p>
+          <a:p>
+            <a:r>
+              <a:rPr lang="en-US" dirty="0" smtClean="0"/>
+              <a:t>Original version of Cube was black and called a ‘</a:t>
+            </a:r>
+            <a:r>
+              <a:rPr lang="en-US" dirty="0" err="1" smtClean="0"/>
+              <a:t>PixHawk</a:t>
+            </a:r>
+            <a:r>
+              <a:rPr lang="en-US" dirty="0" smtClean="0"/>
+              <a:t> 2.1’ but the named changed to just ‘Cube’</a:t>
+            </a:r>
+          </a:p>
+          <a:p>
+            <a:endParaRPr lang="en-US" dirty="0" smtClean="0"/>
+          </a:p>
+          <a:p>
+            <a:endParaRPr lang="en-US" dirty="0"/>
+          </a:p>
+        </p:txBody>
+      </p:sp>
+    </p:spTree>
+    <p:extLst>
+      <p:ext uri="{BB962C8B-B14F-4D97-AF65-F5344CB8AC3E}">
+        <p14:creationId xmlns:p14="http://schemas.microsoft.com/office/powerpoint/2010/main" val="117938741"/>
       </p:ext>
     </p:extLst>
   </p:cSld>

</xml_diff>